<commit_message>
feat: add SYMBIOT 2026 presentation template to public assets
</commit_message>
<xml_diff>
--- a/frontend/public/PPT_template/SYMBIOT_2026_OPEN_PPT.pptx
+++ b/frontend/public/PPT_template/SYMBIOT_2026_OPEN_PPT.pptx
@@ -5058,7 +5058,7 @@
         <p:spPr>
           <a:xfrm>
             <a:off x="2133600" y="6819900"/>
-            <a:ext cx="6604123" cy="819618"/>
+            <a:ext cx="6604123" cy="381643"/>
           </a:xfrm>
           <a:prstGeom prst="rect">
             <a:avLst/>
@@ -5085,17 +5085,10 @@
                 <a:cs typeface="Montserrat Classic Bold"/>
                 <a:sym typeface="Montserrat Classic Bold"/>
               </a:rPr>
-              <a:t>TEAM NAME:</a:t>
-            </a:r>
-          </a:p>
-          <a:p>
-            <a:pPr algn="l">
-              <a:lnSpc>
-                <a:spcPts val="3255"/>
-              </a:lnSpc>
-            </a:pPr>
-            <a:r>
-              <a:rPr lang="en-US" sz="2583" b="1" spc="129" dirty="0">
+              <a:t>TEAM </a:t>
+            </a:r>
+            <a:r>
+              <a:rPr lang="en-US" sz="2583" b="1" spc="129">
                 <a:solidFill>
                   <a:srgbClr val="111630"/>
                 </a:solidFill>
@@ -5104,8 +5097,17 @@
                 <a:cs typeface="Montserrat Classic Bold"/>
                 <a:sym typeface="Montserrat Classic Bold"/>
               </a:rPr>
-              <a:t>PSID:</a:t>
-            </a:r>
+              <a:t>NAME:</a:t>
+            </a:r>
+            <a:endParaRPr lang="en-US" sz="2583" b="1" spc="129" dirty="0">
+              <a:solidFill>
+                <a:srgbClr val="111630"/>
+              </a:solidFill>
+              <a:latin typeface="Montserrat Classic Bold"/>
+              <a:ea typeface="Montserrat Classic Bold"/>
+              <a:cs typeface="Montserrat Classic Bold"/>
+              <a:sym typeface="Montserrat Classic Bold"/>
+            </a:endParaRPr>
           </a:p>
         </p:txBody>
       </p:sp>

</xml_diff>